<commit_message>
[Modify] – Update the proposal PDF and slides to the versions with group number 12
[Modification] docs/proposal/proposal.pdf and proposal-slides.pptx replaced with the rebuild that shows 第 12 組 on the cover and slide footers
</commit_message>
<xml_diff>
--- a/docs/proposal/proposal-slides.pptx
+++ b/docs/proposal/proposal-slides.pptx
@@ -4722,7 +4722,7 @@
                 <a:ea typeface="Microsoft JhengHei"/>
                 <a:cs typeface="Microsoft JhengHei"/>
               </a:rPr>
-              <a:t>AIoT-DA 期末專題提案　｜　第 ＿＿ 組</a:t>
+              <a:t>AIoT-DA 期末專題提案　｜　第 12 組</a:t>
             </a:r>
           </a:p>
         </p:txBody>
@@ -4900,7 +4900,7 @@
                 <a:ea typeface="Microsoft JhengHei"/>
                 <a:cs typeface="Microsoft JhengHei"/>
               </a:rPr>
-              <a:t>AIoT-DA 期末專題提案　｜　第 ＿＿ 組</a:t>
+              <a:t>AIoT-DA 期末專題提案　｜　第 12 組</a:t>
             </a:r>
           </a:p>
         </p:txBody>
@@ -5253,7 +5253,7 @@
                 <a:ea typeface="Microsoft JhengHei"/>
                 <a:cs typeface="Microsoft JhengHei"/>
               </a:rPr>
-              <a:t>AIoT-DA 期末專題提案　｜　第 ＿＿ 組</a:t>
+              <a:t>AIoT-DA 期末專題提案　｜　第 12 組</a:t>
             </a:r>
           </a:p>
         </p:txBody>
@@ -5629,7 +5629,7 @@
                 <a:ea typeface="Microsoft JhengHei"/>
                 <a:cs typeface="Microsoft JhengHei"/>
               </a:rPr>
-              <a:t>AIoT-DA 期末專題提案　｜　第 ＿＿ 組</a:t>
+              <a:t>AIoT-DA 期末專題提案　｜　第 12 組</a:t>
             </a:r>
           </a:p>
         </p:txBody>
@@ -5868,7 +5868,7 @@
                 <a:ea typeface="Microsoft JhengHei"/>
                 <a:cs typeface="Microsoft JhengHei"/>
               </a:rPr>
-              <a:t>AIoT-DA 期末專題提案　｜　第 ＿＿ 組</a:t>
+              <a:t>AIoT-DA 期末專題提案　｜　第 12 組</a:t>
             </a:r>
           </a:p>
         </p:txBody>
@@ -6395,7 +6395,7 @@
                 <a:ea typeface="Microsoft JhengHei"/>
                 <a:cs typeface="Microsoft JhengHei"/>
               </a:rPr>
-              <a:t>AIoT-DA 期末專題提案　｜　第 ＿＿ 組</a:t>
+              <a:t>AIoT-DA 期末專題提案　｜　第 12 組</a:t>
             </a:r>
           </a:p>
         </p:txBody>
@@ -6762,7 +6762,7 @@
                 <a:ea typeface="Microsoft JhengHei"/>
                 <a:cs typeface="Microsoft JhengHei"/>
               </a:rPr>
-              <a:t>AIoT-DA 期末專題提案　｜　第 ＿＿ 組</a:t>
+              <a:t>AIoT-DA 期末專題提案　｜　第 12 組</a:t>
             </a:r>
           </a:p>
         </p:txBody>
@@ -7411,7 +7411,7 @@
                 <a:ea typeface="Microsoft JhengHei"/>
                 <a:cs typeface="Microsoft JhengHei"/>
               </a:rPr>
-              <a:t>AIoT-DA 期末專題提案　｜　第 ＿＿ 組</a:t>
+              <a:t>AIoT-DA 期末專題提案　｜　第 12 組</a:t>
             </a:r>
           </a:p>
         </p:txBody>
@@ -7764,7 +7764,7 @@
                 <a:ea typeface="Microsoft JhengHei"/>
                 <a:cs typeface="Microsoft JhengHei"/>
               </a:rPr>
-              <a:t>AIoT-DA 期末專題提案　｜　第 ＿＿ 組</a:t>
+              <a:t>AIoT-DA 期末專題提案　｜　第 12 組</a:t>
             </a:r>
           </a:p>
         </p:txBody>
@@ -8131,7 +8131,7 @@
                 <a:ea typeface="Microsoft JhengHei"/>
                 <a:cs typeface="Microsoft JhengHei"/>
               </a:rPr>
-              <a:t>AIoT-DA 期末專題提案　｜　第 ＿＿ 組</a:t>
+              <a:t>AIoT-DA 期末專題提案　｜　第 12 組</a:t>
             </a:r>
           </a:p>
         </p:txBody>
@@ -8461,7 +8461,7 @@
                 <a:ea typeface="Microsoft JhengHei"/>
                 <a:cs typeface="Microsoft JhengHei"/>
               </a:rPr>
-              <a:t>AIoT-DA 期末專題提案　｜　第 ＿＿ 組</a:t>
+              <a:t>AIoT-DA 期末專題提案　｜　第 12 組</a:t>
             </a:r>
           </a:p>
         </p:txBody>
@@ -8828,7 +8828,7 @@
                 <a:ea typeface="Microsoft JhengHei"/>
                 <a:cs typeface="Microsoft JhengHei"/>
               </a:rPr>
-              <a:t>AIoT-DA 期末專題提案　｜　第 ＿＿ 組</a:t>
+              <a:t>AIoT-DA 期末專題提案　｜　第 12 組</a:t>
             </a:r>
           </a:p>
         </p:txBody>
@@ -9403,7 +9403,7 @@
                 <a:ea typeface="Microsoft JhengHei"/>
                 <a:cs typeface="Microsoft JhengHei"/>
               </a:rPr>
-              <a:t>AIoT-DA 期末專題提案　｜　第 ＿＿ 組</a:t>
+              <a:t>AIoT-DA 期末專題提案　｜　第 12 組</a:t>
             </a:r>
           </a:p>
         </p:txBody>
@@ -9779,7 +9779,7 @@
                 <a:ea typeface="Microsoft JhengHei"/>
                 <a:cs typeface="Microsoft JhengHei"/>
               </a:rPr>
-              <a:t>AIoT-DA 期末專題提案　｜　第 ＿＿ 組</a:t>
+              <a:t>AIoT-DA 期末專題提案　｜　第 12 組</a:t>
             </a:r>
           </a:p>
         </p:txBody>
@@ -10018,7 +10018,7 @@
                 <a:ea typeface="Microsoft JhengHei"/>
                 <a:cs typeface="Microsoft JhengHei"/>
               </a:rPr>
-              <a:t>AIoT-DA 期末專題提案　｜　第 ＿＿ 組</a:t>
+              <a:t>AIoT-DA 期末專題提案　｜　第 12 組</a:t>
             </a:r>
           </a:p>
         </p:txBody>
@@ -10704,7 +10704,7 @@
                 <a:ea typeface="Microsoft JhengHei"/>
                 <a:cs typeface="Microsoft JhengHei"/>
               </a:rPr>
-              <a:t>AIoT-DA 期末專題提案　｜　第 ＿＿ 組</a:t>
+              <a:t>AIoT-DA 期末專題提案　｜　第 12 組</a:t>
             </a:r>
           </a:p>
         </p:txBody>

</xml_diff>

<commit_message>
[Modify] – Sync DESIGN.md verification rules and Algorithm 1 with the reviewed proposal, and update the slides
[Modification] DESIGN.md §4.2: rule 2 uses the P90 arrival time at each station; rule 3 checks the [P50, P90] arrival window against heavy-rain warnings
[Modification] DESIGN.md §8: replace the condensed Algorithm 1 with the proposal's 21-line version (P50/P90 segment times and arrival times from the pace agent)
[Modification] DESIGN.md §13: add the review-sync entry and correct the creation date
[Modification] docs/proposal/proposal-slides.pptx: slide 10 states the model predicts log moving time; slide 15 E2 is scored against an independent oracle
</commit_message>
<xml_diff>
--- a/docs/proposal/proposal-slides.pptx
+++ b/docs/proposal/proposal-slides.pptx
@@ -587,7 +587,7 @@
           <a:lstStyle/>
           <a:p>
             <a:r>
-              <a:t>分析的核心是個人配速模型。我們手上有二七九趟自己的行程，每一段實際騎了多久，就是模型要學的答案。特徵包括彎道曲率、坡度、道路等級和時段天氣。模型先用課堂教過的多元迴歸當基準，再用分位數損失的梯度提升樹，輸出一般情況和保守情況兩個時間。這裡有個細節：每段的保守時間直接相加會嚴重高估，所以我們用歷史行程校正整趟的範圍。最後會和平均速度、還有 Google 地圖的兩輪車預估時間比較。</a:t>
+              <a:t>分析的核心是個人配速模型。我們手上有二七九趟自己的行程，每一段實際騎了多久，就是模型要學的答案。特徵包括彎道曲率、坡度、道路等級和時段天氣。模型直接預測每段的騎乘時間，先用課堂教過的多元迴歸當基準，再用分位數損失的梯度提升樹，輸出一般和保守兩個時間。這裡有個細節：每段的保守時間直接相加會嚴重高估，所以我們用歷史行程校正整趟的範圍。最後會和平均速度、還有 Google 地圖的兩輪車預估時間比較。</a:t>
             </a:r>
           </a:p>
         </p:txBody>
@@ -937,7 +937,7 @@
           <a:lstStyle/>
           <a:p>
             <a:r>
-              <a:t>評估分成四個實驗。第一個驗證配速模型，和平均速度、Google 預估時間比較，看誤差和保守範圍的覆蓋率。第二個是消融實驗，用同一批規劃問題，比較只用語言模型、加上知識庫、以及完整 Agent 的計畫可行率，這直接回答工具和驗證到底帶來多少改善。第三個用歷史封路紀錄回測風險規則，第四個做完整的案例研究。我們預期個人模型在山路會更準，但這些都還是待驗證的假設，這份提案沒有任何實驗結果。</a:t>
+              <a:t>評估分成四個實驗。第一個驗證配速模型，和平均速度、Google 預估時間比較，看誤差和保守範圍的覆蓋率。第二個是消融實驗，比較只用語言模型、加上知識庫和完整 Agent；評分不用系統自己的規則，而是事先獨立算好的標準答案，看違規率和拒答率。第三個用歷史封路紀錄回測風險規則，第四個做完整的案例研究。我們預期個人模型在山路會更準，但這些都是待驗證的假設，提案不含實驗結果。</a:t>
             </a:r>
           </a:p>
         </p:txBody>
@@ -5029,7 +5029,7 @@
                 <a:ea typeface="Microsoft JhengHei"/>
                 <a:cs typeface="Microsoft JhengHei"/>
               </a:rPr>
-              <a:t>模型：多元迴歸（課程 L6）→ LightGBM 分位數損失，輸出每段 P50 與 P90</a:t>
+              <a:t>模型：多元迴歸（課程 L6）→ LightGBM 分位數損失，直接預測每段移動時間（取對數，不從速度換算），輸出 P50 與 P90</a:t>
             </a:r>
           </a:p>
           <a:p>
@@ -7014,7 +7014,7 @@
                           <a:ea typeface="Microsoft JhengHei"/>
                           <a:cs typeface="Microsoft JhengHei"/>
                         </a:rPr>
-                        <a:t>外部驗證能提高可行率嗎？</a:t>
+                        <a:t>外部驗證能減少違規嗎？</a:t>
                       </a:r>
                     </a:p>
                   </a:txBody>
@@ -7038,7 +7038,7 @@
                           <a:ea typeface="Microsoft JhengHei"/>
                           <a:cs typeface="Microsoft JhengHei"/>
                         </a:rPr>
-                        <a:t>20–30 題規劃問題；只用 LLM vs LLM + 知識庫 vs 完整 Agent；計畫可行率、時間誤差、數字可追溯率</a:t>
+                        <a:t>20–30 題規劃問題；只用 LLM vs LLM + 知識庫 vs 完整 Agent；以事先算好的獨立 oracle 評分：違規率、時間誤差、拒答率</a:t>
                       </a:r>
                     </a:p>
                   </a:txBody>
@@ -7233,7 +7233,7 @@
                 <a:ea typeface="Microsoft JhengHei"/>
                 <a:cs typeface="Microsoft JhengHei"/>
               </a:rPr>
-              <a:t>預期成果（待驗證）：個人配速模型在彎道密集的山區路段比一般導航更貼近實際；完整 Agent 的計畫可行率高於只用 LLM。本提案不含實驗結果。</a:t>
+              <a:t>預期成果（待驗證）：個人配速模型在彎道密集的山區路段比一般導航更貼近實際；完整 Agent 對獨立 oracle 的違規率低於只用 LLM。本提案不含實驗結果。</a:t>
             </a:r>
           </a:p>
         </p:txBody>

</xml_diff>